<commit_message>
Add real GitHub link to app.py, README, create_ppt.py and regenerate PPT
</commit_message>
<xml_diff>
--- a/slides/MediFlowAI_RDMU_Final_Presentation.pptx
+++ b/slides/MediFlowAI_RDMU_Final_Presentation.pptx
@@ -3415,7 +3415,7 @@
                   <a:srgbClr val="86EFAC"/>
                 </a:solidFill>
               </a:rPr>
-              <a:t>GitHub Repo   :  [PASTE_GITHUB_REPO_LINK_HERE]</a:t>
+              <a:t>GitHub Repo   :  https://github.com/krish2105/mediflow-ai-rdmu-final</a:t>
             </a:r>
           </a:p>
         </p:txBody>
@@ -3877,7 +3877,7 @@
                   <a:srgbClr val="93C5FD"/>
                 </a:solidFill>
               </a:rPr>
-              <a:t>Colab: [PASTE_ACCESSIBLE_COLAB_LINK_HERE]   GitHub: [PASTE_GITHUB_REPO_LINK_HERE]   App: [PASTE_STREAMLIT_APP_LINK_HERE]</a:t>
+              <a:t>Colab: [PASTE_ACCESSIBLE_COLAB_LINK_HERE]   GitHub: https://github.com/krish2105/mediflow-ai-rdmu-final   App: [PASTE_STREAMLIT_APP_LINK_HERE]</a:t>
             </a:r>
           </a:p>
         </p:txBody>
@@ -5923,7 +5923,7 @@
                   <a:srgbClr val="86EFAC"/>
                 </a:solidFill>
               </a:rPr>
-              <a:t>App: [PASTE_STREAMLIT_APP_LINK_HERE]   |   GitHub: [PASTE_GITHUB_REPO_LINK_HERE]</a:t>
+              <a:t>App: [PASTE_STREAMLIT_APP_LINK_HERE]   |   GitHub: https://github.com/krish2105/mediflow-ai-rdmu-final</a:t>
             </a:r>
           </a:p>
         </p:txBody>
@@ -5991,7 +5991,7 @@
                   <a:srgbClr val="93C5FD"/>
                 </a:solidFill>
               </a:rPr>
-              <a:t>Colab: [PASTE_ACCESSIBLE_COLAB_LINK_HERE]   GitHub: [PASTE_GITHUB_REPO_LINK_HERE]   App: [PASTE_STREAMLIT_APP_LINK_HERE]</a:t>
+              <a:t>Colab: [PASTE_ACCESSIBLE_COLAB_LINK_HERE]   GitHub: https://github.com/krish2105/mediflow-ai-rdmu-final   App: [PASTE_STREAMLIT_APP_LINK_HERE]</a:t>
             </a:r>
           </a:p>
         </p:txBody>

</xml_diff>

<commit_message>
Add live Colab, GitHub, and Streamlit links to all project files
- COLAB_LINK: colab.research.google.com/drive/1LjqDNOLf4z481r_s1NxHATEMKN2ynbZO
- STREAMLIT_LINK: mediflow-ai-rdmu-final-vyj96f9xwbtezqmelhjq6c.streamlit.app
- Updated: app.py, create_ppt.py, README.md, MediFlowAI_Notebook.ipynb
- Regenerated: slides/MediFlowAI_RDMU_Final_Presentation.pptx (10 slides)

Co-Authored-By: Claude Sonnet 4.6 <noreply@anthropic.com>
</commit_message>
<xml_diff>
--- a/slides/MediFlowAI_RDMU_Final_Presentation.pptx
+++ b/slides/MediFlowAI_RDMU_Final_Presentation.pptx
@@ -3381,7 +3381,7 @@
                   <a:srgbClr val="86EFAC"/>
                 </a:solidFill>
               </a:rPr>
-              <a:t>Google Colab  :  [PASTE_ACCESSIBLE_COLAB_LINK_HERE]</a:t>
+              <a:t>Google Colab  :  https://colab.research.google.com/drive/1LjqDNOLf4z481r_s1NxHATEMKN2ynbZO#scrollTo=2b3c8630</a:t>
             </a:r>
           </a:p>
         </p:txBody>
@@ -3449,7 +3449,7 @@
                   <a:srgbClr val="86EFAC"/>
                 </a:solidFill>
               </a:rPr>
-              <a:t>Streamlit App :  [PASTE_STREAMLIT_APP_LINK_HERE]</a:t>
+              <a:t>Streamlit App :  https://mediflow-ai-rdmu-final-vyj96f9xwbtezqmelhjq6c.streamlit.app/</a:t>
             </a:r>
           </a:p>
         </p:txBody>
@@ -3877,7 +3877,7 @@
                   <a:srgbClr val="93C5FD"/>
                 </a:solidFill>
               </a:rPr>
-              <a:t>Colab: [PASTE_ACCESSIBLE_COLAB_LINK_HERE]   GitHub: https://github.com/krish2105/mediflow-ai-rdmu-final   App: [PASTE_STREAMLIT_APP_LINK_HERE]</a:t>
+              <a:t>Colab: https://colab.research.google.com/drive/1LjqDNOLf4z481r_s1NxHATEMKN2ynbZO#scrollTo=2b3c8630   GitHub: https://github.com/krish2105/mediflow-ai-rdmu-final   App: https://mediflow-ai-rdmu-final-vyj96f9xwbtezqmelhjq6c.streamlit.app/</a:t>
             </a:r>
           </a:p>
         </p:txBody>
@@ -5923,7 +5923,7 @@
                   <a:srgbClr val="86EFAC"/>
                 </a:solidFill>
               </a:rPr>
-              <a:t>App: [PASTE_STREAMLIT_APP_LINK_HERE]   |   GitHub: https://github.com/krish2105/mediflow-ai-rdmu-final</a:t>
+              <a:t>App: https://mediflow-ai-rdmu-final-vyj96f9xwbtezqmelhjq6c.streamlit.app/   |   GitHub: https://github.com/krish2105/mediflow-ai-rdmu-final</a:t>
             </a:r>
           </a:p>
         </p:txBody>
@@ -5991,7 +5991,7 @@
                   <a:srgbClr val="93C5FD"/>
                 </a:solidFill>
               </a:rPr>
-              <a:t>Colab: [PASTE_ACCESSIBLE_COLAB_LINK_HERE]   GitHub: https://github.com/krish2105/mediflow-ai-rdmu-final   App: [PASTE_STREAMLIT_APP_LINK_HERE]</a:t>
+              <a:t>Colab: https://colab.research.google.com/drive/1LjqDNOLf4z481r_s1NxHATEMKN2ynbZO#scrollTo=2b3c8630   GitHub: https://github.com/krish2105/mediflow-ai-rdmu-final   App: https://mediflow-ai-rdmu-final-vyj96f9xwbtezqmelhjq6c.streamlit.app/</a:t>
             </a:r>
           </a:p>
         </p:txBody>

</xml_diff>